<commit_message>
Updated and corrected slides, addes slides on ordinal regression
</commit_message>
<xml_diff>
--- a/LectureSlides/09_GeneralizingTheLinearModel.pptx
+++ b/LectureSlides/09_GeneralizingTheLinearModel.pptx
@@ -5,7 +5,7 @@
     <p:sldMasterId id="2147483648" r:id="rId1"/>
   </p:sldMasterIdLst>
   <p:notesMasterIdLst>
-    <p:notesMasterId r:id="rId64"/>
+    <p:notesMasterId r:id="rId68"/>
   </p:notesMasterIdLst>
   <p:sldIdLst>
     <p:sldId id="308" r:id="rId2"/>
@@ -68,8 +68,12 @@
     <p:sldId id="304" r:id="rId59"/>
     <p:sldId id="305" r:id="rId60"/>
     <p:sldId id="306" r:id="rId61"/>
-    <p:sldId id="327" r:id="rId62"/>
-    <p:sldId id="307" r:id="rId63"/>
+    <p:sldId id="338" r:id="rId62"/>
+    <p:sldId id="339" r:id="rId63"/>
+    <p:sldId id="340" r:id="rId64"/>
+    <p:sldId id="337" r:id="rId65"/>
+    <p:sldId id="327" r:id="rId66"/>
+    <p:sldId id="307" r:id="rId67"/>
   </p:sldIdLst>
   <p:sldSz cx="9144000" cy="5143500" type="screen16x9"/>
   <p:notesSz cx="6858000" cy="9144000"/>
@@ -269,7 +273,7 @@
           <a:p>
             <a:fld id="{35BCC803-D91A-40A8-8BFC-49FB40BF6589}" type="datetimeFigureOut">
               <a:rPr lang="en-US" smtClean="0"/>
-              <a:t>9/28/2026</a:t>
+              <a:t>9/29/2026</a:t>
             </a:fld>
             <a:endParaRPr lang="en-US"/>
           </a:p>
@@ -625,7 +629,7 @@
           <a:p>
             <a:fld id="{979D3DEE-884F-4AC4-B40C-E4221C7984B1}" type="slidenum">
               <a:rPr lang="en-US" smtClean="0"/>
-              <a:t>61</a:t>
+              <a:t>65</a:t>
             </a:fld>
             <a:endParaRPr lang="en-US"/>
           </a:p>
@@ -709,7 +713,7 @@
           <a:p>
             <a:fld id="{979D3DEE-884F-4AC4-B40C-E4221C7984B1}" type="slidenum">
               <a:rPr lang="en-US" smtClean="0"/>
-              <a:t>62</a:t>
+              <a:t>66</a:t>
             </a:fld>
             <a:endParaRPr lang="en-US"/>
           </a:p>
@@ -907,7 +911,7 @@
           <a:p>
             <a:fld id="{241EB5C9-1307-BA42-ABA2-0BC069CD8E7F}" type="datetimeFigureOut">
               <a:rPr lang="en-US" smtClean="0"/>
-              <a:t>9/28/2026</a:t>
+              <a:t>9/29/2026</a:t>
             </a:fld>
             <a:endParaRPr lang="en-US"/>
           </a:p>
@@ -1075,7 +1079,7 @@
           <a:p>
             <a:fld id="{241EB5C9-1307-BA42-ABA2-0BC069CD8E7F}" type="datetimeFigureOut">
               <a:rPr lang="en-US" smtClean="0"/>
-              <a:t>9/28/2026</a:t>
+              <a:t>9/29/2026</a:t>
             </a:fld>
             <a:endParaRPr lang="en-US"/>
           </a:p>
@@ -1253,7 +1257,7 @@
           <a:p>
             <a:fld id="{241EB5C9-1307-BA42-ABA2-0BC069CD8E7F}" type="datetimeFigureOut">
               <a:rPr lang="en-US" smtClean="0"/>
-              <a:t>9/28/2026</a:t>
+              <a:t>9/29/2026</a:t>
             </a:fld>
             <a:endParaRPr lang="en-US"/>
           </a:p>
@@ -1421,7 +1425,7 @@
           <a:p>
             <a:fld id="{241EB5C9-1307-BA42-ABA2-0BC069CD8E7F}" type="datetimeFigureOut">
               <a:rPr lang="en-US" smtClean="0"/>
-              <a:t>9/28/2026</a:t>
+              <a:t>9/29/2026</a:t>
             </a:fld>
             <a:endParaRPr lang="en-US"/>
           </a:p>
@@ -1666,7 +1670,7 @@
           <a:p>
             <a:fld id="{241EB5C9-1307-BA42-ABA2-0BC069CD8E7F}" type="datetimeFigureOut">
               <a:rPr lang="en-US" smtClean="0"/>
-              <a:t>9/28/2026</a:t>
+              <a:t>9/29/2026</a:t>
             </a:fld>
             <a:endParaRPr lang="en-US"/>
           </a:p>
@@ -1951,7 +1955,7 @@
           <a:p>
             <a:fld id="{241EB5C9-1307-BA42-ABA2-0BC069CD8E7F}" type="datetimeFigureOut">
               <a:rPr lang="en-US" smtClean="0"/>
-              <a:t>9/28/2026</a:t>
+              <a:t>9/29/2026</a:t>
             </a:fld>
             <a:endParaRPr lang="en-US"/>
           </a:p>
@@ -2370,7 +2374,7 @@
           <a:p>
             <a:fld id="{241EB5C9-1307-BA42-ABA2-0BC069CD8E7F}" type="datetimeFigureOut">
               <a:rPr lang="en-US" smtClean="0"/>
-              <a:t>9/28/2026</a:t>
+              <a:t>9/29/2026</a:t>
             </a:fld>
             <a:endParaRPr lang="en-US"/>
           </a:p>
@@ -2487,7 +2491,7 @@
           <a:p>
             <a:fld id="{241EB5C9-1307-BA42-ABA2-0BC069CD8E7F}" type="datetimeFigureOut">
               <a:rPr lang="en-US" smtClean="0"/>
-              <a:t>9/28/2026</a:t>
+              <a:t>9/29/2026</a:t>
             </a:fld>
             <a:endParaRPr lang="en-US"/>
           </a:p>
@@ -2582,7 +2586,7 @@
           <a:p>
             <a:fld id="{241EB5C9-1307-BA42-ABA2-0BC069CD8E7F}" type="datetimeFigureOut">
               <a:rPr lang="en-US" smtClean="0"/>
-              <a:t>9/28/2026</a:t>
+              <a:t>9/29/2026</a:t>
             </a:fld>
             <a:endParaRPr lang="en-US"/>
           </a:p>
@@ -2857,7 +2861,7 @@
           <a:p>
             <a:fld id="{241EB5C9-1307-BA42-ABA2-0BC069CD8E7F}" type="datetimeFigureOut">
               <a:rPr lang="en-US" smtClean="0"/>
-              <a:t>9/28/2026</a:t>
+              <a:t>9/29/2026</a:t>
             </a:fld>
             <a:endParaRPr lang="en-US"/>
           </a:p>
@@ -3109,7 +3113,7 @@
           <a:p>
             <a:fld id="{241EB5C9-1307-BA42-ABA2-0BC069CD8E7F}" type="datetimeFigureOut">
               <a:rPr lang="en-US" smtClean="0"/>
-              <a:t>9/28/2026</a:t>
+              <a:t>9/29/2026</a:t>
             </a:fld>
             <a:endParaRPr lang="en-US"/>
           </a:p>
@@ -3320,7 +3324,7 @@
           <a:p>
             <a:fld id="{241EB5C9-1307-BA42-ABA2-0BC069CD8E7F}" type="datetimeFigureOut">
               <a:rPr lang="en-US" smtClean="0"/>
-              <a:t>9/28/2026</a:t>
+              <a:t>9/29/2026</a:t>
             </a:fld>
             <a:endParaRPr lang="en-US"/>
           </a:p>
@@ -5485,7 +5489,7 @@
                           <m:begChr m:val="["/>
                           <m:endChr m:val="]"/>
                           <m:ctrlPr>
-                            <a:rPr lang="ar-AE" i="1">
+                            <a:rPr lang="ar-AE" b="0" i="1" smtClean="0">
                               <a:latin typeface="Cambria Math" panose="02040503050406030204" pitchFamily="18" charset="0"/>
                             </a:rPr>
                           </m:ctrlPr>
@@ -14012,8 +14016,8 @@
           </a:p>
         </p:txBody>
       </p:sp>
-      <mc:AlternateContent xmlns:mc="http://schemas.openxmlformats.org/markup-compatibility/2006" xmlns:a14="http://schemas.microsoft.com/office/drawing/2010/main">
-        <mc:Choice Requires="a14">
+      <mc:AlternateContent xmlns:mc="http://schemas.openxmlformats.org/markup-compatibility/2006">
+        <mc:Choice xmlns:a14="http://schemas.microsoft.com/office/drawing/2010/main" Requires="a14">
           <p:sp>
             <p:nvSpPr>
               <p:cNvPr id="3" name="Content Placeholder 2">
@@ -14090,7 +14094,7 @@
                 </a:r>
                 <a:r>
                   <a:rPr lang="en-US" b="1" dirty="0"/>
-                  <a:t>variable value </a:t>
+                  <a:t>fixed variable value </a:t>
                 </a:r>
                 <a14:m>
                   <m:oMath xmlns:m="http://schemas.openxmlformats.org/officeDocument/2006/math">
@@ -14122,7 +14126,7 @@
             </p:txBody>
           </p:sp>
         </mc:Choice>
-        <mc:Fallback xmlns="">
+        <mc:Fallback>
           <p:sp>
             <p:nvSpPr>
               <p:cNvPr id="3" name="Content Placeholder 2">
@@ -20474,7 +20478,7 @@
         </p:spPr>
         <p:txBody>
           <a:bodyPr>
-            <a:normAutofit fontScale="92500" lnSpcReduction="10000"/>
+            <a:normAutofit fontScale="92500"/>
           </a:bodyPr>
           <a:lstStyle/>
           <a:p>
@@ -20507,18 +20511,15 @@
             <a:pPr lvl="0"/>
             <a:r>
               <a:rPr dirty="0"/>
-              <a:t>Logistic regression widely used as a classif</a:t>
+              <a:t>Logistic regression is linear model, with a</a:t>
             </a:r>
             <a:r>
               <a:rPr lang="en-US" dirty="0"/>
-              <a:t>ier</a:t>
-            </a:r>
-          </a:p>
-          <a:p>
-            <a:pPr lvl="0"/>
+              <a:t> discrete</a:t>
+            </a:r>
             <a:r>
               <a:rPr dirty="0"/>
-              <a:t>Logistic regression is linear model, with a binary response or label values, </a:t>
+              <a:t> binary response, </a:t>
             </a:r>
             <a:r>
               <a:rPr dirty="0">
@@ -20770,33 +20771,15 @@
                                   </p:childTnLst>
                                 </p:cTn>
                               </p:par>
-                            </p:childTnLst>
-                          </p:cTn>
-                        </p:par>
-                      </p:childTnLst>
-                    </p:cTn>
-                  </p:par>
-                  <p:par>
-                    <p:cTn id="19" fill="hold">
-                      <p:stCondLst>
-                        <p:cond delay="indefinite"/>
-                      </p:stCondLst>
-                      <p:childTnLst>
-                        <p:par>
-                          <p:cTn id="20" fill="hold">
-                            <p:stCondLst>
-                              <p:cond delay="0"/>
-                            </p:stCondLst>
-                            <p:childTnLst>
                               <p:par>
-                                <p:cTn id="21" presetID="1" presetClass="entr" presetSubtype="0" fill="hold" nodeType="clickEffect">
+                                <p:cTn id="19" presetID="1" presetClass="entr" presetSubtype="0" fill="hold" nodeType="withEffect">
                                   <p:stCondLst>
                                     <p:cond delay="0"/>
                                   </p:stCondLst>
                                   <p:childTnLst>
                                     <p:set>
                                       <p:cBhvr>
-                                        <p:cTn id="22" dur="1" fill="hold">
+                                        <p:cTn id="20" dur="1" fill="hold">
                                           <p:stCondLst>
                                             <p:cond delay="0"/>
                                           </p:stCondLst>
@@ -20820,14 +20803,14 @@
                                 </p:cTn>
                               </p:par>
                               <p:par>
-                                <p:cTn id="23" presetID="1" presetClass="entr" presetSubtype="0" fill="hold" nodeType="withEffect">
+                                <p:cTn id="21" presetID="1" presetClass="entr" presetSubtype="0" fill="hold" nodeType="withEffect">
                                   <p:stCondLst>
                                     <p:cond delay="0"/>
                                   </p:stCondLst>
                                   <p:childTnLst>
                                     <p:set>
                                       <p:cBhvr>
-                                        <p:cTn id="24" dur="1" fill="hold">
+                                        <p:cTn id="22" dur="1" fill="hold">
                                           <p:stCondLst>
                                             <p:cond delay="0"/>
                                           </p:stCondLst>
@@ -20836,37 +20819,6 @@
                                           <p:spTgt spid="3">
                                             <p:txEl>
                                               <p:pRg st="6" end="6"/>
-                                            </p:txEl>
-                                          </p:spTgt>
-                                        </p:tgtEl>
-                                        <p:attrNameLst>
-                                          <p:attrName>style.visibility</p:attrName>
-                                        </p:attrNameLst>
-                                      </p:cBhvr>
-                                      <p:to>
-                                        <p:strVal val="visible"/>
-                                      </p:to>
-                                    </p:set>
-                                  </p:childTnLst>
-                                </p:cTn>
-                              </p:par>
-                              <p:par>
-                                <p:cTn id="25" presetID="1" presetClass="entr" presetSubtype="0" fill="hold" nodeType="withEffect">
-                                  <p:stCondLst>
-                                    <p:cond delay="0"/>
-                                  </p:stCondLst>
-                                  <p:childTnLst>
-                                    <p:set>
-                                      <p:cBhvr>
-                                        <p:cTn id="26" dur="1" fill="hold">
-                                          <p:stCondLst>
-                                            <p:cond delay="0"/>
-                                          </p:stCondLst>
-                                        </p:cTn>
-                                        <p:tgtEl>
-                                          <p:spTgt spid="3">
-                                            <p:txEl>
-                                              <p:pRg st="7" end="7"/>
                                             </p:txEl>
                                           </p:spTgt>
                                         </p:tgtEl>
@@ -20953,8 +20905,8 @@
           </a:p>
         </p:txBody>
       </p:sp>
-      <mc:AlternateContent xmlns:mc="http://schemas.openxmlformats.org/markup-compatibility/2006" xmlns:a14="http://schemas.microsoft.com/office/drawing/2010/main">
-        <mc:Choice Requires="a14">
+      <mc:AlternateContent xmlns:mc="http://schemas.openxmlformats.org/markup-compatibility/2006">
+        <mc:Choice xmlns:a14="http://schemas.microsoft.com/office/drawing/2010/main" Requires="a14">
           <p:sp>
             <p:nvSpPr>
               <p:cNvPr id="3" name="Content Placeholder 2"/>
@@ -20973,7 +20925,7 @@
             </p:spPr>
             <p:txBody>
               <a:bodyPr>
-                <a:normAutofit lnSpcReduction="10000"/>
+                <a:normAutofit fontScale="92500" lnSpcReduction="20000"/>
               </a:bodyPr>
               <a:lstStyle/>
               <a:p>
@@ -21071,29 +21023,17 @@
                       </m:sub>
                     </m:sSub>
                     <m:r>
-                      <a:rPr lang="en-US" b="0" i="1" smtClean="0">
-                        <a:latin typeface="Cambria Math" panose="02040503050406030204" pitchFamily="18" charset="0"/>
-                      </a:rPr>
-                      <m:t>)</m:t>
-                    </m:r>
-                    <m:r>
                       <a:rPr lang="ar-AE">
                         <a:latin typeface="Cambria Math" panose="02040503050406030204" pitchFamily="18" charset="0"/>
                       </a:rPr>
                       <m:t>=1</m:t>
                     </m:r>
-                  </m:oMath>
-                </a14:m>
-                <a:r>
-                  <a:rPr lang="en-US" dirty="0"/>
-                  <a:t>,</a:t>
-                </a:r>
-                <a:r>
-                  <a:rPr lang="ar-AE" dirty="0"/>
-                  <a:t> </a:t>
-                </a:r>
-                <a14:m>
-                  <m:oMath xmlns:m="http://schemas.openxmlformats.org/officeDocument/2006/math">
+                    <m:r>
+                      <a:rPr lang="en-US" b="0" i="0" smtClean="0">
+                        <a:latin typeface="Cambria Math" panose="02040503050406030204" pitchFamily="18" charset="0"/>
+                      </a:rPr>
+                      <m:t>)=</m:t>
+                    </m:r>
                     <m:sSub>
                       <m:sSubPr>
                         <m:ctrlPr>
@@ -21361,62 +21301,260 @@
                       <m:f>
                         <m:fPr>
                           <m:ctrlPr>
-                            <a:rPr lang="en-US" b="0" i="1" smtClean="0">
+                            <a:rPr lang="en-US" i="1">
                               <a:latin typeface="Cambria Math" panose="02040503050406030204" pitchFamily="18" charset="0"/>
                             </a:rPr>
                           </m:ctrlPr>
                         </m:fPr>
                         <m:num>
-                          <m:r>
-                            <a:rPr lang="en-US" b="0" i="1" smtClean="0">
-                              <a:latin typeface="Cambria Math" panose="02040503050406030204" pitchFamily="18" charset="0"/>
-                            </a:rPr>
-                            <m:t>𝑝𝑟𝑜𝑏𝑎𝑏𝑖𝑙𝑖𝑡𝑦</m:t>
-                          </m:r>
-                          <m:r>
-                            <a:rPr lang="en-US" b="0" i="1" smtClean="0">
-                              <a:latin typeface="Cambria Math" panose="02040503050406030204" pitchFamily="18" charset="0"/>
-                            </a:rPr>
-                            <m:t> </m:t>
-                          </m:r>
-                          <m:r>
-                            <a:rPr lang="en-US" b="0" i="1" smtClean="0">
-                              <a:latin typeface="Cambria Math" panose="02040503050406030204" pitchFamily="18" charset="0"/>
-                            </a:rPr>
-                            <m:t>𝑜𝑓</m:t>
-                          </m:r>
-                          <m:r>
-                            <a:rPr lang="en-US" b="0" i="1" smtClean="0">
-                              <a:latin typeface="Cambria Math" panose="02040503050406030204" pitchFamily="18" charset="0"/>
-                            </a:rPr>
-                            <m:t> 1</m:t>
-                          </m:r>
+                          <m:f>
+                            <m:fPr>
+                              <m:ctrlPr>
+                                <a:rPr lang="en-US" i="1">
+                                  <a:latin typeface="Cambria Math" panose="02040503050406030204" pitchFamily="18" charset="0"/>
+                                </a:rPr>
+                              </m:ctrlPr>
+                            </m:fPr>
+                            <m:num>
+                              <m:sSub>
+                                <m:sSubPr>
+                                  <m:ctrlPr>
+                                    <a:rPr lang="en-US" i="1">
+                                      <a:latin typeface="Cambria Math" panose="02040503050406030204" pitchFamily="18" charset="0"/>
+                                    </a:rPr>
+                                  </m:ctrlPr>
+                                </m:sSubPr>
+                                <m:e>
+                                  <m:r>
+                                    <a:rPr lang="en-US" i="1">
+                                      <a:latin typeface="Cambria Math" panose="02040503050406030204" pitchFamily="18" charset="0"/>
+                                    </a:rPr>
+                                    <m:t>𝑃</m:t>
+                                  </m:r>
+                                  <m:r>
+                                    <a:rPr lang="en-US" i="1">
+                                      <a:latin typeface="Cambria Math" panose="02040503050406030204" pitchFamily="18" charset="0"/>
+                                    </a:rPr>
+                                    <m:t>(</m:t>
+                                  </m:r>
+                                  <m:r>
+                                    <a:rPr lang="ar-AE">
+                                      <a:latin typeface="Cambria Math" panose="02040503050406030204" pitchFamily="18" charset="0"/>
+                                    </a:rPr>
+                                    <m:t>𝑦</m:t>
+                                  </m:r>
+                                </m:e>
+                                <m:sub>
+                                  <m:r>
+                                    <a:rPr lang="ar-AE">
+                                      <a:latin typeface="Cambria Math" panose="02040503050406030204" pitchFamily="18" charset="0"/>
+                                    </a:rPr>
+                                    <m:t>𝑖</m:t>
+                                  </m:r>
+                                </m:sub>
+                              </m:sSub>
+                              <m:r>
+                                <a:rPr lang="ar-AE">
+                                  <a:latin typeface="Cambria Math" panose="02040503050406030204" pitchFamily="18" charset="0"/>
+                                </a:rPr>
+                                <m:t>=1</m:t>
+                              </m:r>
+                              <m:r>
+                                <a:rPr lang="en-US">
+                                  <a:latin typeface="Cambria Math" panose="02040503050406030204" pitchFamily="18" charset="0"/>
+                                </a:rPr>
+                                <m:t>)</m:t>
+                              </m:r>
+                            </m:num>
+                            <m:den>
+                              <m:r>
+                                <a:rPr lang="en-US" i="1">
+                                  <a:latin typeface="Cambria Math" panose="02040503050406030204" pitchFamily="18" charset="0"/>
+                                </a:rPr>
+                                <m:t>1−</m:t>
+                              </m:r>
+                              <m:sSub>
+                                <m:sSubPr>
+                                  <m:ctrlPr>
+                                    <a:rPr lang="en-US" i="1">
+                                      <a:latin typeface="Cambria Math" panose="02040503050406030204" pitchFamily="18" charset="0"/>
+                                    </a:rPr>
+                                  </m:ctrlPr>
+                                </m:sSubPr>
+                                <m:e>
+                                  <m:r>
+                                    <a:rPr lang="en-US" i="1">
+                                      <a:latin typeface="Cambria Math" panose="02040503050406030204" pitchFamily="18" charset="0"/>
+                                    </a:rPr>
+                                    <m:t>𝑃</m:t>
+                                  </m:r>
+                                  <m:r>
+                                    <a:rPr lang="en-US" i="1">
+                                      <a:latin typeface="Cambria Math" panose="02040503050406030204" pitchFamily="18" charset="0"/>
+                                    </a:rPr>
+                                    <m:t>(</m:t>
+                                  </m:r>
+                                  <m:r>
+                                    <a:rPr lang="ar-AE">
+                                      <a:latin typeface="Cambria Math" panose="02040503050406030204" pitchFamily="18" charset="0"/>
+                                    </a:rPr>
+                                    <m:t>𝑦</m:t>
+                                  </m:r>
+                                </m:e>
+                                <m:sub>
+                                  <m:r>
+                                    <a:rPr lang="ar-AE">
+                                      <a:latin typeface="Cambria Math" panose="02040503050406030204" pitchFamily="18" charset="0"/>
+                                    </a:rPr>
+                                    <m:t>𝑖</m:t>
+                                  </m:r>
+                                </m:sub>
+                              </m:sSub>
+                              <m:r>
+                                <a:rPr lang="ar-AE">
+                                  <a:latin typeface="Cambria Math" panose="02040503050406030204" pitchFamily="18" charset="0"/>
+                                </a:rPr>
+                                <m:t>=1</m:t>
+                              </m:r>
+                              <m:r>
+                                <a:rPr lang="en-US">
+                                  <a:latin typeface="Cambria Math" panose="02040503050406030204" pitchFamily="18" charset="0"/>
+                                </a:rPr>
+                                <m:t>)</m:t>
+                              </m:r>
+                            </m:den>
+                          </m:f>
                         </m:num>
                         <m:den>
-                          <m:r>
-                            <a:rPr lang="en-US" b="0" i="1" smtClean="0">
-                              <a:latin typeface="Cambria Math" panose="02040503050406030204" pitchFamily="18" charset="0"/>
-                            </a:rPr>
-                            <m:t>𝑝𝑟𝑜𝑏𝑎𝑏𝑖𝑙𝑖𝑡𝑦</m:t>
-                          </m:r>
-                          <m:r>
-                            <a:rPr lang="en-US" b="0" i="1" smtClean="0">
-                              <a:latin typeface="Cambria Math" panose="02040503050406030204" pitchFamily="18" charset="0"/>
-                            </a:rPr>
-                            <m:t> </m:t>
-                          </m:r>
-                          <m:r>
-                            <a:rPr lang="en-US" b="0" i="1" smtClean="0">
-                              <a:latin typeface="Cambria Math" panose="02040503050406030204" pitchFamily="18" charset="0"/>
-                            </a:rPr>
-                            <m:t>𝑜𝑓</m:t>
-                          </m:r>
-                          <m:r>
-                            <a:rPr lang="en-US" b="0" i="1" smtClean="0">
-                              <a:latin typeface="Cambria Math" panose="02040503050406030204" pitchFamily="18" charset="0"/>
-                            </a:rPr>
-                            <m:t> 0</m:t>
-                          </m:r>
+                          <m:f>
+                            <m:fPr>
+                              <m:ctrlPr>
+                                <a:rPr lang="en-US" i="1">
+                                  <a:latin typeface="Cambria Math" panose="02040503050406030204" pitchFamily="18" charset="0"/>
+                                </a:rPr>
+                              </m:ctrlPr>
+                            </m:fPr>
+                            <m:num>
+                              <m:sSub>
+                                <m:sSubPr>
+                                  <m:ctrlPr>
+                                    <a:rPr lang="en-US" i="1">
+                                      <a:latin typeface="Cambria Math" panose="02040503050406030204" pitchFamily="18" charset="0"/>
+                                    </a:rPr>
+                                  </m:ctrlPr>
+                                </m:sSubPr>
+                                <m:e>
+                                  <m:r>
+                                    <a:rPr lang="en-US" i="1">
+                                      <a:latin typeface="Cambria Math" panose="02040503050406030204" pitchFamily="18" charset="0"/>
+                                    </a:rPr>
+                                    <m:t>𝑃</m:t>
+                                  </m:r>
+                                  <m:r>
+                                    <a:rPr lang="en-US" i="1">
+                                      <a:latin typeface="Cambria Math" panose="02040503050406030204" pitchFamily="18" charset="0"/>
+                                    </a:rPr>
+                                    <m:t>(</m:t>
+                                  </m:r>
+                                  <m:r>
+                                    <a:rPr lang="ar-AE">
+                                      <a:latin typeface="Cambria Math" panose="02040503050406030204" pitchFamily="18" charset="0"/>
+                                    </a:rPr>
+                                    <m:t>𝑦</m:t>
+                                  </m:r>
+                                </m:e>
+                                <m:sub>
+                                  <m:r>
+                                    <a:rPr lang="ar-AE">
+                                      <a:latin typeface="Cambria Math" panose="02040503050406030204" pitchFamily="18" charset="0"/>
+                                    </a:rPr>
+                                    <m:t>𝑖</m:t>
+                                  </m:r>
+                                </m:sub>
+                              </m:sSub>
+                              <m:r>
+                                <a:rPr lang="ar-AE">
+                                  <a:latin typeface="Cambria Math" panose="02040503050406030204" pitchFamily="18" charset="0"/>
+                                </a:rPr>
+                                <m:t>=</m:t>
+                              </m:r>
+                              <m:r>
+                                <a:rPr lang="en-US">
+                                  <a:latin typeface="Cambria Math" panose="02040503050406030204" pitchFamily="18" charset="0"/>
+                                </a:rPr>
+                                <m:t>0</m:t>
+                              </m:r>
+                              <m:r>
+                                <a:rPr lang="en-US">
+                                  <a:latin typeface="Cambria Math" panose="02040503050406030204" pitchFamily="18" charset="0"/>
+                                </a:rPr>
+                                <m:t>)</m:t>
+                              </m:r>
+                            </m:num>
+                            <m:den>
+                              <m:r>
+                                <a:rPr lang="en-US" i="1">
+                                  <a:latin typeface="Cambria Math" panose="02040503050406030204" pitchFamily="18" charset="0"/>
+                                </a:rPr>
+                                <m:t>1−</m:t>
+                              </m:r>
+                              <m:sSub>
+                                <m:sSubPr>
+                                  <m:ctrlPr>
+                                    <a:rPr lang="en-US" i="1">
+                                      <a:latin typeface="Cambria Math" panose="02040503050406030204" pitchFamily="18" charset="0"/>
+                                    </a:rPr>
+                                  </m:ctrlPr>
+                                </m:sSubPr>
+                                <m:e>
+                                  <m:r>
+                                    <a:rPr lang="en-US" i="1">
+                                      <a:latin typeface="Cambria Math" panose="02040503050406030204" pitchFamily="18" charset="0"/>
+                                    </a:rPr>
+                                    <m:t>𝑃</m:t>
+                                  </m:r>
+                                  <m:r>
+                                    <a:rPr lang="en-US" i="1">
+                                      <a:latin typeface="Cambria Math" panose="02040503050406030204" pitchFamily="18" charset="0"/>
+                                    </a:rPr>
+                                    <m:t>(</m:t>
+                                  </m:r>
+                                  <m:r>
+                                    <a:rPr lang="ar-AE">
+                                      <a:latin typeface="Cambria Math" panose="02040503050406030204" pitchFamily="18" charset="0"/>
+                                    </a:rPr>
+                                    <m:t>𝑦</m:t>
+                                  </m:r>
+                                </m:e>
+                                <m:sub>
+                                  <m:r>
+                                    <a:rPr lang="ar-AE">
+                                      <a:latin typeface="Cambria Math" panose="02040503050406030204" pitchFamily="18" charset="0"/>
+                                    </a:rPr>
+                                    <m:t>𝑖</m:t>
+                                  </m:r>
+                                </m:sub>
+                              </m:sSub>
+                              <m:r>
+                                <a:rPr lang="ar-AE">
+                                  <a:latin typeface="Cambria Math" panose="02040503050406030204" pitchFamily="18" charset="0"/>
+                                </a:rPr>
+                                <m:t>=</m:t>
+                              </m:r>
+                              <m:r>
+                                <a:rPr lang="en-US">
+                                  <a:latin typeface="Cambria Math" panose="02040503050406030204" pitchFamily="18" charset="0"/>
+                                </a:rPr>
+                                <m:t>0</m:t>
+                              </m:r>
+                              <m:r>
+                                <a:rPr lang="en-US">
+                                  <a:latin typeface="Cambria Math" panose="02040503050406030204" pitchFamily="18" charset="0"/>
+                                </a:rPr>
+                                <m:t>)</m:t>
+                              </m:r>
+                            </m:den>
+                          </m:f>
                         </m:den>
                       </m:f>
                       <m:r>
@@ -21574,7 +21712,7 @@
             </p:txBody>
           </p:sp>
         </mc:Choice>
-        <mc:Fallback xmlns="">
+        <mc:Fallback>
           <p:sp>
             <p:nvSpPr>
               <p:cNvPr id="3" name="Content Placeholder 2"/>
@@ -21593,7 +21731,7 @@
               <a:blipFill>
                 <a:blip r:embed="rId2"/>
                 <a:stretch>
-                  <a:fillRect l="-1111" t="-2389"/>
+                  <a:fillRect l="-963" t="-2901"/>
                 </a:stretch>
               </a:blipFill>
             </p:spPr>
@@ -21617,289 +21755,6 @@
   <p:clrMapOvr>
     <a:masterClrMapping/>
   </p:clrMapOvr>
-  <p:timing>
-    <p:tnLst>
-      <p:par>
-        <p:cTn id="1" dur="indefinite" restart="never" nodeType="tmRoot">
-          <p:childTnLst>
-            <p:seq concurrent="1" nextAc="seek">
-              <p:cTn id="2" dur="indefinite" nodeType="mainSeq">
-                <p:childTnLst>
-                  <p:par>
-                    <p:cTn id="3" fill="hold">
-                      <p:stCondLst>
-                        <p:cond delay="indefinite"/>
-                      </p:stCondLst>
-                      <p:childTnLst>
-                        <p:par>
-                          <p:cTn id="4" fill="hold">
-                            <p:stCondLst>
-                              <p:cond delay="0"/>
-                            </p:stCondLst>
-                            <p:childTnLst>
-                              <p:par>
-                                <p:cTn id="5" presetID="1" presetClass="entr" presetSubtype="0" fill="hold" nodeType="clickEffect">
-                                  <p:stCondLst>
-                                    <p:cond delay="0"/>
-                                  </p:stCondLst>
-                                  <p:childTnLst>
-                                    <p:set>
-                                      <p:cBhvr>
-                                        <p:cTn id="6" dur="1" fill="hold">
-                                          <p:stCondLst>
-                                            <p:cond delay="0"/>
-                                          </p:stCondLst>
-                                        </p:cTn>
-                                        <p:tgtEl>
-                                          <p:spTgt spid="3">
-                                            <p:txEl>
-                                              <p:pRg st="1" end="1"/>
-                                            </p:txEl>
-                                          </p:spTgt>
-                                        </p:tgtEl>
-                                        <p:attrNameLst>
-                                          <p:attrName>style.visibility</p:attrName>
-                                        </p:attrNameLst>
-                                      </p:cBhvr>
-                                      <p:to>
-                                        <p:strVal val="visible"/>
-                                      </p:to>
-                                    </p:set>
-                                  </p:childTnLst>
-                                </p:cTn>
-                              </p:par>
-                              <p:par>
-                                <p:cTn id="7" presetID="1" presetClass="entr" presetSubtype="0" fill="hold" nodeType="withEffect">
-                                  <p:stCondLst>
-                                    <p:cond delay="0"/>
-                                  </p:stCondLst>
-                                  <p:childTnLst>
-                                    <p:set>
-                                      <p:cBhvr>
-                                        <p:cTn id="8" dur="1" fill="hold">
-                                          <p:stCondLst>
-                                            <p:cond delay="0"/>
-                                          </p:stCondLst>
-                                        </p:cTn>
-                                        <p:tgtEl>
-                                          <p:spTgt spid="3">
-                                            <p:txEl>
-                                              <p:pRg st="2" end="2"/>
-                                            </p:txEl>
-                                          </p:spTgt>
-                                        </p:tgtEl>
-                                        <p:attrNameLst>
-                                          <p:attrName>style.visibility</p:attrName>
-                                        </p:attrNameLst>
-                                      </p:cBhvr>
-                                      <p:to>
-                                        <p:strVal val="visible"/>
-                                      </p:to>
-                                    </p:set>
-                                  </p:childTnLst>
-                                </p:cTn>
-                              </p:par>
-                              <p:par>
-                                <p:cTn id="9" presetID="1" presetClass="entr" presetSubtype="0" fill="hold" nodeType="withEffect">
-                                  <p:stCondLst>
-                                    <p:cond delay="0"/>
-                                  </p:stCondLst>
-                                  <p:childTnLst>
-                                    <p:set>
-                                      <p:cBhvr>
-                                        <p:cTn id="10" dur="1" fill="hold">
-                                          <p:stCondLst>
-                                            <p:cond delay="0"/>
-                                          </p:stCondLst>
-                                        </p:cTn>
-                                        <p:tgtEl>
-                                          <p:spTgt spid="3">
-                                            <p:txEl>
-                                              <p:pRg st="3" end="3"/>
-                                            </p:txEl>
-                                          </p:spTgt>
-                                        </p:tgtEl>
-                                        <p:attrNameLst>
-                                          <p:attrName>style.visibility</p:attrName>
-                                        </p:attrNameLst>
-                                      </p:cBhvr>
-                                      <p:to>
-                                        <p:strVal val="visible"/>
-                                      </p:to>
-                                    </p:set>
-                                  </p:childTnLst>
-                                </p:cTn>
-                              </p:par>
-                              <p:par>
-                                <p:cTn id="11" presetID="1" presetClass="entr" presetSubtype="0" fill="hold" nodeType="withEffect">
-                                  <p:stCondLst>
-                                    <p:cond delay="0"/>
-                                  </p:stCondLst>
-                                  <p:childTnLst>
-                                    <p:set>
-                                      <p:cBhvr>
-                                        <p:cTn id="12" dur="1" fill="hold">
-                                          <p:stCondLst>
-                                            <p:cond delay="0"/>
-                                          </p:stCondLst>
-                                        </p:cTn>
-                                        <p:tgtEl>
-                                          <p:spTgt spid="3">
-                                            <p:txEl>
-                                              <p:pRg st="4" end="4"/>
-                                            </p:txEl>
-                                          </p:spTgt>
-                                        </p:tgtEl>
-                                        <p:attrNameLst>
-                                          <p:attrName>style.visibility</p:attrName>
-                                        </p:attrNameLst>
-                                      </p:cBhvr>
-                                      <p:to>
-                                        <p:strVal val="visible"/>
-                                      </p:to>
-                                    </p:set>
-                                  </p:childTnLst>
-                                </p:cTn>
-                              </p:par>
-                              <p:par>
-                                <p:cTn id="13" presetID="1" presetClass="entr" presetSubtype="0" fill="hold" nodeType="withEffect">
-                                  <p:stCondLst>
-                                    <p:cond delay="0"/>
-                                  </p:stCondLst>
-                                  <p:childTnLst>
-                                    <p:set>
-                                      <p:cBhvr>
-                                        <p:cTn id="14" dur="1" fill="hold">
-                                          <p:stCondLst>
-                                            <p:cond delay="0"/>
-                                          </p:stCondLst>
-                                        </p:cTn>
-                                        <p:tgtEl>
-                                          <p:spTgt spid="3">
-                                            <p:txEl>
-                                              <p:pRg st="5" end="5"/>
-                                            </p:txEl>
-                                          </p:spTgt>
-                                        </p:tgtEl>
-                                        <p:attrNameLst>
-                                          <p:attrName>style.visibility</p:attrName>
-                                        </p:attrNameLst>
-                                      </p:cBhvr>
-                                      <p:to>
-                                        <p:strVal val="visible"/>
-                                      </p:to>
-                                    </p:set>
-                                  </p:childTnLst>
-                                </p:cTn>
-                              </p:par>
-                            </p:childTnLst>
-                          </p:cTn>
-                        </p:par>
-                      </p:childTnLst>
-                    </p:cTn>
-                  </p:par>
-                  <p:par>
-                    <p:cTn id="15" fill="hold">
-                      <p:stCondLst>
-                        <p:cond delay="indefinite"/>
-                      </p:stCondLst>
-                      <p:childTnLst>
-                        <p:par>
-                          <p:cTn id="16" fill="hold">
-                            <p:stCondLst>
-                              <p:cond delay="0"/>
-                            </p:stCondLst>
-                            <p:childTnLst>
-                              <p:par>
-                                <p:cTn id="17" presetID="1" presetClass="entr" presetSubtype="0" fill="hold" nodeType="clickEffect">
-                                  <p:stCondLst>
-                                    <p:cond delay="0"/>
-                                  </p:stCondLst>
-                                  <p:childTnLst>
-                                    <p:set>
-                                      <p:cBhvr>
-                                        <p:cTn id="18" dur="1" fill="hold">
-                                          <p:stCondLst>
-                                            <p:cond delay="0"/>
-                                          </p:stCondLst>
-                                        </p:cTn>
-                                        <p:tgtEl>
-                                          <p:spTgt spid="3">
-                                            <p:txEl>
-                                              <p:pRg st="6" end="6"/>
-                                            </p:txEl>
-                                          </p:spTgt>
-                                        </p:tgtEl>
-                                        <p:attrNameLst>
-                                          <p:attrName>style.visibility</p:attrName>
-                                        </p:attrNameLst>
-                                      </p:cBhvr>
-                                      <p:to>
-                                        <p:strVal val="visible"/>
-                                      </p:to>
-                                    </p:set>
-                                  </p:childTnLst>
-                                </p:cTn>
-                              </p:par>
-                              <p:par>
-                                <p:cTn id="19" presetID="1" presetClass="entr" presetSubtype="0" fill="hold" nodeType="withEffect">
-                                  <p:stCondLst>
-                                    <p:cond delay="0"/>
-                                  </p:stCondLst>
-                                  <p:childTnLst>
-                                    <p:set>
-                                      <p:cBhvr>
-                                        <p:cTn id="20" dur="1" fill="hold">
-                                          <p:stCondLst>
-                                            <p:cond delay="0"/>
-                                          </p:stCondLst>
-                                        </p:cTn>
-                                        <p:tgtEl>
-                                          <p:spTgt spid="3">
-                                            <p:txEl>
-                                              <p:pRg st="7" end="7"/>
-                                            </p:txEl>
-                                          </p:spTgt>
-                                        </p:tgtEl>
-                                        <p:attrNameLst>
-                                          <p:attrName>style.visibility</p:attrName>
-                                        </p:attrNameLst>
-                                      </p:cBhvr>
-                                      <p:to>
-                                        <p:strVal val="visible"/>
-                                      </p:to>
-                                    </p:set>
-                                  </p:childTnLst>
-                                </p:cTn>
-                              </p:par>
-                            </p:childTnLst>
-                          </p:cTn>
-                        </p:par>
-                      </p:childTnLst>
-                    </p:cTn>
-                  </p:par>
-                </p:childTnLst>
-              </p:cTn>
-              <p:prevCondLst>
-                <p:cond evt="onPrev" delay="0">
-                  <p:tgtEl>
-                    <p:sldTgt/>
-                  </p:tgtEl>
-                </p:cond>
-              </p:prevCondLst>
-              <p:nextCondLst>
-                <p:cond evt="onNext" delay="0">
-                  <p:tgtEl>
-                    <p:sldTgt/>
-                  </p:tgtEl>
-                </p:cond>
-              </p:nextCondLst>
-            </p:seq>
-          </p:childTnLst>
-        </p:cTn>
-      </p:par>
-    </p:tnLst>
-  </p:timing>
 </p:sld>
 </file>
 
@@ -23105,6 +22960,7 @@
                           <m:ctrlPr>
                             <a:rPr lang="en-US" i="1">
                               <a:latin typeface="Cambria Math" panose="02040503050406030204" pitchFamily="18" charset="0"/>
+                              <a:ea typeface="Cambria Math" panose="02040503050406030204" pitchFamily="18" charset="0"/>
                             </a:rPr>
                           </m:ctrlPr>
                         </m:sSubPr>
@@ -23426,7 +23282,7 @@
                       <m:d>
                         <m:dPr>
                           <m:ctrlPr>
-                            <a:rPr lang="ar-AE" i="1">
+                            <a:rPr lang="en-US" b="0" i="1" smtClean="0">
                               <a:latin typeface="Cambria Math" panose="02040503050406030204" pitchFamily="18" charset="0"/>
                             </a:rPr>
                           </m:ctrlPr>
@@ -32665,7 +32521,7 @@
                       <m:d>
                         <m:dPr>
                           <m:ctrlPr>
-                            <a:rPr lang="en-US" b="0" i="1" smtClean="0">
+                            <a:rPr lang="ar-AE" i="1">
                               <a:latin typeface="Cambria Math" panose="02040503050406030204" pitchFamily="18" charset="0"/>
                             </a:rPr>
                           </m:ctrlPr>
@@ -39523,6 +39379,7 @@
                           <m:ctrlPr>
                             <a:rPr lang="en-US" b="0" i="1" smtClean="0">
                               <a:latin typeface="Cambria Math" panose="02040503050406030204" pitchFamily="18" charset="0"/>
+                              <a:ea typeface="Cambria Math" panose="02040503050406030204" pitchFamily="18" charset="0"/>
                             </a:rPr>
                           </m:ctrlPr>
                         </m:fPr>
@@ -43606,6 +43463,782 @@
         <p:cNvPr id="1" name="">
           <a:extLst>
             <a:ext uri="{FF2B5EF4-FFF2-40B4-BE49-F238E27FC236}">
+              <a16:creationId xmlns:a16="http://schemas.microsoft.com/office/drawing/2014/main" id="{88F7F695-D1C6-0DFF-7782-7EFEE1A0BECD}"/>
+            </a:ext>
+          </a:extLst>
+        </p:cNvPr>
+        <p:cNvGrpSpPr/>
+        <p:nvPr/>
+      </p:nvGrpSpPr>
+      <p:grpSpPr>
+        <a:xfrm>
+          <a:off x="0" y="0"/>
+          <a:ext cx="0" cy="0"/>
+          <a:chOff x="0" y="0"/>
+          <a:chExt cx="0" cy="0"/>
+        </a:xfrm>
+      </p:grpSpPr>
+      <p:sp>
+        <p:nvSpPr>
+          <p:cNvPr id="2" name="Title 1">
+            <a:extLst>
+              <a:ext uri="{FF2B5EF4-FFF2-40B4-BE49-F238E27FC236}">
+                <a16:creationId xmlns:a16="http://schemas.microsoft.com/office/drawing/2014/main" id="{864581DD-AFEF-CF00-9905-1F2D7F285DAD}"/>
+              </a:ext>
+            </a:extLst>
+          </p:cNvPr>
+          <p:cNvSpPr>
+            <a:spLocks noGrp="1"/>
+          </p:cNvSpPr>
+          <p:nvPr>
+            <p:ph type="ctrTitle"/>
+          </p:nvPr>
+        </p:nvSpPr>
+        <p:spPr/>
+        <p:txBody>
+          <a:bodyPr/>
+          <a:lstStyle/>
+          <a:p>
+            <a:r>
+              <a:rPr lang="en-US" dirty="0"/>
+              <a:t>Ordinal Regression </a:t>
+            </a:r>
+          </a:p>
+        </p:txBody>
+      </p:sp>
+    </p:spTree>
+    <p:extLst>
+      <p:ext uri="{BB962C8B-B14F-4D97-AF65-F5344CB8AC3E}">
+        <p14:creationId xmlns:p14="http://schemas.microsoft.com/office/powerpoint/2010/main" val="2926988659"/>
+      </p:ext>
+    </p:extLst>
+  </p:cSld>
+  <p:clrMapOvr>
+    <a:masterClrMapping/>
+  </p:clrMapOvr>
+</p:sld>
+</file>
+
+<file path=ppt/slides/slide62.xml><?xml version="1.0" encoding="utf-8"?>
+<p:sld xmlns:a="http://schemas.openxmlformats.org/drawingml/2006/main" xmlns:r="http://schemas.openxmlformats.org/officeDocument/2006/relationships" xmlns:p="http://schemas.openxmlformats.org/presentationml/2006/main">
+  <p:cSld>
+    <p:spTree>
+      <p:nvGrpSpPr>
+        <p:cNvPr id="1" name="">
+          <a:extLst>
+            <a:ext uri="{FF2B5EF4-FFF2-40B4-BE49-F238E27FC236}">
+              <a16:creationId xmlns:a16="http://schemas.microsoft.com/office/drawing/2014/main" id="{D3F87FCC-2F15-05A8-72C7-6E37D9B34595}"/>
+            </a:ext>
+          </a:extLst>
+        </p:cNvPr>
+        <p:cNvGrpSpPr/>
+        <p:nvPr/>
+      </p:nvGrpSpPr>
+      <p:grpSpPr>
+        <a:xfrm>
+          <a:off x="0" y="0"/>
+          <a:ext cx="0" cy="0"/>
+          <a:chOff x="0" y="0"/>
+          <a:chExt cx="0" cy="0"/>
+        </a:xfrm>
+      </p:grpSpPr>
+      <p:sp>
+        <p:nvSpPr>
+          <p:cNvPr id="2" name="Title 1">
+            <a:extLst>
+              <a:ext uri="{FF2B5EF4-FFF2-40B4-BE49-F238E27FC236}">
+                <a16:creationId xmlns:a16="http://schemas.microsoft.com/office/drawing/2014/main" id="{03456D64-0B84-563B-8907-41C08659B54B}"/>
+              </a:ext>
+            </a:extLst>
+          </p:cNvPr>
+          <p:cNvSpPr>
+            <a:spLocks noGrp="1"/>
+          </p:cNvSpPr>
+          <p:nvPr>
+            <p:ph type="title"/>
+          </p:nvPr>
+        </p:nvSpPr>
+        <p:spPr/>
+        <p:txBody>
+          <a:bodyPr/>
+          <a:lstStyle/>
+          <a:p>
+            <a:pPr marL="0" lvl="0" indent="0">
+              <a:buNone/>
+            </a:pPr>
+            <a:r>
+              <a:rPr lang="en-US" dirty="0"/>
+              <a:t>Ordinal regression </a:t>
+            </a:r>
+            <a:endParaRPr dirty="0"/>
+          </a:p>
+        </p:txBody>
+      </p:sp>
+      <mc:AlternateContent xmlns:mc="http://schemas.openxmlformats.org/markup-compatibility/2006">
+        <mc:Choice xmlns:a14="http://schemas.microsoft.com/office/drawing/2010/main" Requires="a14">
+          <p:sp>
+            <p:nvSpPr>
+              <p:cNvPr id="3" name="Content Placeholder 2">
+                <a:extLst>
+                  <a:ext uri="{FF2B5EF4-FFF2-40B4-BE49-F238E27FC236}">
+                    <a16:creationId xmlns:a16="http://schemas.microsoft.com/office/drawing/2014/main" id="{FDCC5C27-9615-6DC7-8E87-E9A919758ECD}"/>
+                  </a:ext>
+                </a:extLst>
+              </p:cNvPr>
+              <p:cNvSpPr>
+                <a:spLocks noGrp="1"/>
+              </p:cNvSpPr>
+              <p:nvPr>
+                <p:ph idx="1"/>
+              </p:nvPr>
+            </p:nvSpPr>
+            <p:spPr/>
+            <p:txBody>
+              <a:bodyPr>
+                <a:normAutofit/>
+              </a:bodyPr>
+              <a:lstStyle/>
+              <a:p>
+                <a:pPr marL="0" lvl="0" indent="0">
+                  <a:buNone/>
+                </a:pPr>
+                <a:r>
+                  <a:rPr lang="en-US" dirty="0"/>
+                  <a:t>How do we create a model for ordered responses? </a:t>
+                </a:r>
+              </a:p>
+              <a:p>
+                <a:pPr lvl="0"/>
+                <a:r>
+                  <a:rPr lang="en-US" dirty="0"/>
+                  <a:t>The rank in the n-level ordered response needs to be estimated     </a:t>
+                </a:r>
+              </a:p>
+              <a:p>
+                <a:pPr marL="0" lvl="0" indent="0">
+                  <a:buNone/>
+                </a:pPr>
+                <a14:m>
+                  <m:oMathPara xmlns:m="http://schemas.openxmlformats.org/officeDocument/2006/math">
+                    <m:oMath>
+                      <m:sSub>
+                        <m:sSubPr>
+                          <m:ctrlPr>
+                            <a:rPr lang="en-US" b="0" i="1" smtClean="0">
+                              <a:latin typeface="Cambria Math" panose="02040503050406030204" pitchFamily="18" charset="0"/>
+                            </a:rPr>
+                          </m:ctrlPr>
+                        </m:sSubPr>
+                        <m:e>
+                          <m:r>
+                            <a:rPr lang="en-US" b="0" i="1" smtClean="0">
+                              <a:latin typeface="Cambria Math" panose="02040503050406030204" pitchFamily="18" charset="0"/>
+                            </a:rPr>
+                            <m:t>𝑟</m:t>
+                          </m:r>
+                        </m:e>
+                        <m:sub>
+                          <m:r>
+                            <a:rPr lang="en-US" b="0" i="1" smtClean="0">
+                              <a:latin typeface="Cambria Math" panose="02040503050406030204" pitchFamily="18" charset="0"/>
+                            </a:rPr>
+                            <m:t>1</m:t>
+                          </m:r>
+                        </m:sub>
+                      </m:sSub>
+                      <m:r>
+                        <a:rPr lang="en-US" i="1" smtClean="0">
+                          <a:latin typeface="Cambria Math" panose="02040503050406030204" pitchFamily="18" charset="0"/>
+                          <a:ea typeface="Cambria Math" panose="02040503050406030204" pitchFamily="18" charset="0"/>
+                        </a:rPr>
+                        <m:t>≺</m:t>
+                      </m:r>
+                      <m:sSub>
+                        <m:sSubPr>
+                          <m:ctrlPr>
+                            <a:rPr lang="en-US" b="0" i="1" smtClean="0">
+                              <a:latin typeface="Cambria Math" panose="02040503050406030204" pitchFamily="18" charset="0"/>
+                              <a:ea typeface="Cambria Math" panose="02040503050406030204" pitchFamily="18" charset="0"/>
+                            </a:rPr>
+                          </m:ctrlPr>
+                        </m:sSubPr>
+                        <m:e>
+                          <m:r>
+                            <a:rPr lang="en-US" b="0" i="1" smtClean="0">
+                              <a:latin typeface="Cambria Math" panose="02040503050406030204" pitchFamily="18" charset="0"/>
+                              <a:ea typeface="Cambria Math" panose="02040503050406030204" pitchFamily="18" charset="0"/>
+                            </a:rPr>
+                            <m:t>𝑟</m:t>
+                          </m:r>
+                        </m:e>
+                        <m:sub>
+                          <m:r>
+                            <a:rPr lang="en-US" b="0" i="1" smtClean="0">
+                              <a:latin typeface="Cambria Math" panose="02040503050406030204" pitchFamily="18" charset="0"/>
+                              <a:ea typeface="Cambria Math" panose="02040503050406030204" pitchFamily="18" charset="0"/>
+                            </a:rPr>
+                            <m:t>2</m:t>
+                          </m:r>
+                        </m:sub>
+                      </m:sSub>
+                      <m:r>
+                        <a:rPr lang="en-US" i="1">
+                          <a:latin typeface="Cambria Math" panose="02040503050406030204" pitchFamily="18" charset="0"/>
+                          <a:ea typeface="Cambria Math" panose="02040503050406030204" pitchFamily="18" charset="0"/>
+                        </a:rPr>
+                        <m:t>≺</m:t>
+                      </m:r>
+                      <m:sSub>
+                        <m:sSubPr>
+                          <m:ctrlPr>
+                            <a:rPr lang="en-US" i="1">
+                              <a:latin typeface="Cambria Math" panose="02040503050406030204" pitchFamily="18" charset="0"/>
+                              <a:ea typeface="Cambria Math" panose="02040503050406030204" pitchFamily="18" charset="0"/>
+                            </a:rPr>
+                          </m:ctrlPr>
+                        </m:sSubPr>
+                        <m:e>
+                          <m:r>
+                            <a:rPr lang="en-US" i="1">
+                              <a:latin typeface="Cambria Math" panose="02040503050406030204" pitchFamily="18" charset="0"/>
+                              <a:ea typeface="Cambria Math" panose="02040503050406030204" pitchFamily="18" charset="0"/>
+                            </a:rPr>
+                            <m:t>𝑟</m:t>
+                          </m:r>
+                        </m:e>
+                        <m:sub>
+                          <m:r>
+                            <a:rPr lang="en-US" b="0" i="1" smtClean="0">
+                              <a:latin typeface="Cambria Math" panose="02040503050406030204" pitchFamily="18" charset="0"/>
+                              <a:ea typeface="Cambria Math" panose="02040503050406030204" pitchFamily="18" charset="0"/>
+                            </a:rPr>
+                            <m:t>3</m:t>
+                          </m:r>
+                        </m:sub>
+                      </m:sSub>
+                      <m:r>
+                        <a:rPr lang="en-US" b="0" i="1" smtClean="0">
+                          <a:latin typeface="Cambria Math" panose="02040503050406030204" pitchFamily="18" charset="0"/>
+                          <a:ea typeface="Cambria Math" panose="02040503050406030204" pitchFamily="18" charset="0"/>
+                        </a:rPr>
+                        <m:t>…</m:t>
+                      </m:r>
+                      <m:r>
+                        <a:rPr lang="en-US" i="1">
+                          <a:latin typeface="Cambria Math" panose="02040503050406030204" pitchFamily="18" charset="0"/>
+                          <a:ea typeface="Cambria Math" panose="02040503050406030204" pitchFamily="18" charset="0"/>
+                        </a:rPr>
+                        <m:t>≺</m:t>
+                      </m:r>
+                      <m:sSub>
+                        <m:sSubPr>
+                          <m:ctrlPr>
+                            <a:rPr lang="en-US" i="1">
+                              <a:latin typeface="Cambria Math" panose="02040503050406030204" pitchFamily="18" charset="0"/>
+                              <a:ea typeface="Cambria Math" panose="02040503050406030204" pitchFamily="18" charset="0"/>
+                            </a:rPr>
+                          </m:ctrlPr>
+                        </m:sSubPr>
+                        <m:e>
+                          <m:r>
+                            <a:rPr lang="en-US" i="1">
+                              <a:latin typeface="Cambria Math" panose="02040503050406030204" pitchFamily="18" charset="0"/>
+                              <a:ea typeface="Cambria Math" panose="02040503050406030204" pitchFamily="18" charset="0"/>
+                            </a:rPr>
+                            <m:t>𝑟</m:t>
+                          </m:r>
+                        </m:e>
+                        <m:sub>
+                          <m:r>
+                            <a:rPr lang="en-US" b="0" i="1" smtClean="0">
+                              <a:latin typeface="Cambria Math" panose="02040503050406030204" pitchFamily="18" charset="0"/>
+                              <a:ea typeface="Cambria Math" panose="02040503050406030204" pitchFamily="18" charset="0"/>
+                            </a:rPr>
+                            <m:t>𝑛</m:t>
+                          </m:r>
+                        </m:sub>
+                      </m:sSub>
+                    </m:oMath>
+                  </m:oMathPara>
+                </a14:m>
+                <a:endParaRPr lang="en-US" dirty="0"/>
+              </a:p>
+              <a:p>
+                <a:pPr lvl="0"/>
+                <a:r>
+                  <a:rPr lang="en-US" dirty="0"/>
+                  <a:t>We need to estimate the probabilities for the ranks   </a:t>
+                </a:r>
+              </a:p>
+              <a:p>
+                <a:pPr lvl="1"/>
+                <a:r>
+                  <a:rPr lang="en-US" dirty="0"/>
+                  <a:t>Logit model estimates probabilities of the ranks      </a:t>
+                </a:r>
+              </a:p>
+              <a:p>
+                <a:pPr lvl="1"/>
+                <a:r>
+                  <a:rPr lang="en-US" dirty="0"/>
+                  <a:t>Probit model estimates log odds of the ranks </a:t>
+                </a:r>
+                <a:endParaRPr dirty="0"/>
+              </a:p>
+            </p:txBody>
+          </p:sp>
+        </mc:Choice>
+        <mc:Fallback>
+          <p:sp>
+            <p:nvSpPr>
+              <p:cNvPr id="3" name="Content Placeholder 2">
+                <a:extLst>
+                  <a:ext uri="{FF2B5EF4-FFF2-40B4-BE49-F238E27FC236}">
+                    <a16:creationId xmlns:a16="http://schemas.microsoft.com/office/drawing/2014/main" id="{FDCC5C27-9615-6DC7-8E87-E9A919758ECD}"/>
+                  </a:ext>
+                </a:extLst>
+              </p:cNvPr>
+              <p:cNvSpPr>
+                <a:spLocks noGrp="1" noRot="1" noChangeAspect="1" noMove="1" noResize="1" noEditPoints="1" noAdjustHandles="1" noChangeArrowheads="1" noChangeShapeType="1" noTextEdit="1"/>
+              </p:cNvSpPr>
+              <p:nvPr>
+                <p:ph idx="1"/>
+              </p:nvPr>
+            </p:nvSpPr>
+            <p:spPr>
+              <a:blipFill>
+                <a:blip r:embed="rId2"/>
+                <a:stretch>
+                  <a:fillRect l="-1111" t="-1436"/>
+                </a:stretch>
+              </a:blipFill>
+            </p:spPr>
+            <p:txBody>
+              <a:bodyPr/>
+              <a:lstStyle/>
+              <a:p>
+                <a:r>
+                  <a:rPr lang="en-US">
+                    <a:noFill/>
+                  </a:rPr>
+                  <a:t> </a:t>
+                </a:r>
+              </a:p>
+            </p:txBody>
+          </p:sp>
+        </mc:Fallback>
+      </mc:AlternateContent>
+    </p:spTree>
+    <p:extLst>
+      <p:ext uri="{BB962C8B-B14F-4D97-AF65-F5344CB8AC3E}">
+        <p14:creationId xmlns:p14="http://schemas.microsoft.com/office/powerpoint/2010/main" val="3661048809"/>
+      </p:ext>
+    </p:extLst>
+  </p:cSld>
+  <p:clrMapOvr>
+    <a:masterClrMapping/>
+  </p:clrMapOvr>
+</p:sld>
+</file>
+
+<file path=ppt/slides/slide63.xml><?xml version="1.0" encoding="utf-8"?>
+<p:sld xmlns:a="http://schemas.openxmlformats.org/drawingml/2006/main" xmlns:r="http://schemas.openxmlformats.org/officeDocument/2006/relationships" xmlns:p="http://schemas.openxmlformats.org/presentationml/2006/main">
+  <p:cSld>
+    <p:spTree>
+      <p:nvGrpSpPr>
+        <p:cNvPr id="1" name="">
+          <a:extLst>
+            <a:ext uri="{FF2B5EF4-FFF2-40B4-BE49-F238E27FC236}">
+              <a16:creationId xmlns:a16="http://schemas.microsoft.com/office/drawing/2014/main" id="{9A5DAAF5-4CBD-441B-54B6-6F87B14BE9EA}"/>
+            </a:ext>
+          </a:extLst>
+        </p:cNvPr>
+        <p:cNvGrpSpPr/>
+        <p:nvPr/>
+      </p:nvGrpSpPr>
+      <p:grpSpPr>
+        <a:xfrm>
+          <a:off x="0" y="0"/>
+          <a:ext cx="0" cy="0"/>
+          <a:chOff x="0" y="0"/>
+          <a:chExt cx="0" cy="0"/>
+        </a:xfrm>
+      </p:grpSpPr>
+      <p:sp>
+        <p:nvSpPr>
+          <p:cNvPr id="2" name="Title 1">
+            <a:extLst>
+              <a:ext uri="{FF2B5EF4-FFF2-40B4-BE49-F238E27FC236}">
+                <a16:creationId xmlns:a16="http://schemas.microsoft.com/office/drawing/2014/main" id="{317EB637-FF53-8B85-1C22-6C61E0B59AEB}"/>
+              </a:ext>
+            </a:extLst>
+          </p:cNvPr>
+          <p:cNvSpPr>
+            <a:spLocks noGrp="1"/>
+          </p:cNvSpPr>
+          <p:nvPr>
+            <p:ph type="title"/>
+          </p:nvPr>
+        </p:nvSpPr>
+        <p:spPr/>
+        <p:txBody>
+          <a:bodyPr/>
+          <a:lstStyle/>
+          <a:p>
+            <a:pPr marL="0" lvl="0" indent="0">
+              <a:buNone/>
+            </a:pPr>
+            <a:r>
+              <a:rPr lang="en-US" dirty="0"/>
+              <a:t>Ordinal regression </a:t>
+            </a:r>
+            <a:endParaRPr dirty="0"/>
+          </a:p>
+        </p:txBody>
+      </p:sp>
+      <mc:AlternateContent xmlns:mc="http://schemas.openxmlformats.org/markup-compatibility/2006">
+        <mc:Choice xmlns:a14="http://schemas.microsoft.com/office/drawing/2010/main" Requires="a14">
+          <p:sp>
+            <p:nvSpPr>
+              <p:cNvPr id="3" name="Content Placeholder 2">
+                <a:extLst>
+                  <a:ext uri="{FF2B5EF4-FFF2-40B4-BE49-F238E27FC236}">
+                    <a16:creationId xmlns:a16="http://schemas.microsoft.com/office/drawing/2014/main" id="{CB6070E2-70F7-A018-6E47-2030E69C1725}"/>
+                  </a:ext>
+                </a:extLst>
+              </p:cNvPr>
+              <p:cNvSpPr>
+                <a:spLocks noGrp="1"/>
+              </p:cNvSpPr>
+              <p:nvPr>
+                <p:ph idx="1"/>
+              </p:nvPr>
+            </p:nvSpPr>
+            <p:spPr/>
+            <p:txBody>
+              <a:bodyPr>
+                <a:normAutofit/>
+              </a:bodyPr>
+              <a:lstStyle/>
+              <a:p>
+                <a:pPr marL="0" lvl="0" indent="0">
+                  <a:buNone/>
+                </a:pPr>
+                <a:r>
+                  <a:rPr lang="en-US" dirty="0"/>
+                  <a:t>How do we create a model for ordered responses? </a:t>
+                </a:r>
+              </a:p>
+              <a:p>
+                <a:pPr lvl="0"/>
+                <a:r>
+                  <a:rPr lang="en-US" dirty="0"/>
+                  <a:t>The rank in the n-level ordered response needs to be estimated     </a:t>
+                </a:r>
+              </a:p>
+              <a:p>
+                <a:pPr marL="0" lvl="0" indent="0">
+                  <a:buNone/>
+                </a:pPr>
+                <a14:m>
+                  <m:oMathPara xmlns:m="http://schemas.openxmlformats.org/officeDocument/2006/math">
+                    <m:oMath>
+                      <m:sSub>
+                        <m:sSubPr>
+                          <m:ctrlPr>
+                            <a:rPr lang="en-US" b="0" i="1" smtClean="0">
+                              <a:latin typeface="Cambria Math" panose="02040503050406030204" pitchFamily="18" charset="0"/>
+                            </a:rPr>
+                          </m:ctrlPr>
+                        </m:sSubPr>
+                        <m:e>
+                          <m:r>
+                            <a:rPr lang="en-US" b="0" i="1" smtClean="0">
+                              <a:latin typeface="Cambria Math" panose="02040503050406030204" pitchFamily="18" charset="0"/>
+                            </a:rPr>
+                            <m:t>𝑟</m:t>
+                          </m:r>
+                        </m:e>
+                        <m:sub>
+                          <m:r>
+                            <a:rPr lang="en-US" b="0" i="1" smtClean="0">
+                              <a:latin typeface="Cambria Math" panose="02040503050406030204" pitchFamily="18" charset="0"/>
+                            </a:rPr>
+                            <m:t>1</m:t>
+                          </m:r>
+                        </m:sub>
+                      </m:sSub>
+                      <m:r>
+                        <a:rPr lang="en-US" i="1" smtClean="0">
+                          <a:latin typeface="Cambria Math" panose="02040503050406030204" pitchFamily="18" charset="0"/>
+                          <a:ea typeface="Cambria Math" panose="02040503050406030204" pitchFamily="18" charset="0"/>
+                        </a:rPr>
+                        <m:t>≺</m:t>
+                      </m:r>
+                      <m:sSub>
+                        <m:sSubPr>
+                          <m:ctrlPr>
+                            <a:rPr lang="en-US" b="0" i="1" smtClean="0">
+                              <a:latin typeface="Cambria Math" panose="02040503050406030204" pitchFamily="18" charset="0"/>
+                              <a:ea typeface="Cambria Math" panose="02040503050406030204" pitchFamily="18" charset="0"/>
+                            </a:rPr>
+                          </m:ctrlPr>
+                        </m:sSubPr>
+                        <m:e>
+                          <m:r>
+                            <a:rPr lang="en-US" b="0" i="1" smtClean="0">
+                              <a:latin typeface="Cambria Math" panose="02040503050406030204" pitchFamily="18" charset="0"/>
+                              <a:ea typeface="Cambria Math" panose="02040503050406030204" pitchFamily="18" charset="0"/>
+                            </a:rPr>
+                            <m:t>𝑟</m:t>
+                          </m:r>
+                        </m:e>
+                        <m:sub>
+                          <m:r>
+                            <a:rPr lang="en-US" b="0" i="1" smtClean="0">
+                              <a:latin typeface="Cambria Math" panose="02040503050406030204" pitchFamily="18" charset="0"/>
+                              <a:ea typeface="Cambria Math" panose="02040503050406030204" pitchFamily="18" charset="0"/>
+                            </a:rPr>
+                            <m:t>2</m:t>
+                          </m:r>
+                        </m:sub>
+                      </m:sSub>
+                      <m:r>
+                        <a:rPr lang="en-US" i="1">
+                          <a:latin typeface="Cambria Math" panose="02040503050406030204" pitchFamily="18" charset="0"/>
+                          <a:ea typeface="Cambria Math" panose="02040503050406030204" pitchFamily="18" charset="0"/>
+                        </a:rPr>
+                        <m:t>≺</m:t>
+                      </m:r>
+                      <m:sSub>
+                        <m:sSubPr>
+                          <m:ctrlPr>
+                            <a:rPr lang="en-US" i="1">
+                              <a:latin typeface="Cambria Math" panose="02040503050406030204" pitchFamily="18" charset="0"/>
+                              <a:ea typeface="Cambria Math" panose="02040503050406030204" pitchFamily="18" charset="0"/>
+                            </a:rPr>
+                          </m:ctrlPr>
+                        </m:sSubPr>
+                        <m:e>
+                          <m:r>
+                            <a:rPr lang="en-US" i="1">
+                              <a:latin typeface="Cambria Math" panose="02040503050406030204" pitchFamily="18" charset="0"/>
+                              <a:ea typeface="Cambria Math" panose="02040503050406030204" pitchFamily="18" charset="0"/>
+                            </a:rPr>
+                            <m:t>𝑟</m:t>
+                          </m:r>
+                        </m:e>
+                        <m:sub>
+                          <m:r>
+                            <a:rPr lang="en-US" b="0" i="1" smtClean="0">
+                              <a:latin typeface="Cambria Math" panose="02040503050406030204" pitchFamily="18" charset="0"/>
+                              <a:ea typeface="Cambria Math" panose="02040503050406030204" pitchFamily="18" charset="0"/>
+                            </a:rPr>
+                            <m:t>3</m:t>
+                          </m:r>
+                        </m:sub>
+                      </m:sSub>
+                      <m:r>
+                        <a:rPr lang="en-US" b="0" i="1" smtClean="0">
+                          <a:latin typeface="Cambria Math" panose="02040503050406030204" pitchFamily="18" charset="0"/>
+                          <a:ea typeface="Cambria Math" panose="02040503050406030204" pitchFamily="18" charset="0"/>
+                        </a:rPr>
+                        <m:t>…</m:t>
+                      </m:r>
+                      <m:r>
+                        <a:rPr lang="en-US" i="1">
+                          <a:latin typeface="Cambria Math" panose="02040503050406030204" pitchFamily="18" charset="0"/>
+                          <a:ea typeface="Cambria Math" panose="02040503050406030204" pitchFamily="18" charset="0"/>
+                        </a:rPr>
+                        <m:t>≺</m:t>
+                      </m:r>
+                      <m:sSub>
+                        <m:sSubPr>
+                          <m:ctrlPr>
+                            <a:rPr lang="en-US" i="1">
+                              <a:latin typeface="Cambria Math" panose="02040503050406030204" pitchFamily="18" charset="0"/>
+                              <a:ea typeface="Cambria Math" panose="02040503050406030204" pitchFamily="18" charset="0"/>
+                            </a:rPr>
+                          </m:ctrlPr>
+                        </m:sSubPr>
+                        <m:e>
+                          <m:r>
+                            <a:rPr lang="en-US" i="1">
+                              <a:latin typeface="Cambria Math" panose="02040503050406030204" pitchFamily="18" charset="0"/>
+                              <a:ea typeface="Cambria Math" panose="02040503050406030204" pitchFamily="18" charset="0"/>
+                            </a:rPr>
+                            <m:t>𝑟</m:t>
+                          </m:r>
+                        </m:e>
+                        <m:sub>
+                          <m:r>
+                            <a:rPr lang="en-US" b="0" i="1" smtClean="0">
+                              <a:latin typeface="Cambria Math" panose="02040503050406030204" pitchFamily="18" charset="0"/>
+                              <a:ea typeface="Cambria Math" panose="02040503050406030204" pitchFamily="18" charset="0"/>
+                            </a:rPr>
+                            <m:t>𝑛</m:t>
+                          </m:r>
+                        </m:sub>
+                      </m:sSub>
+                    </m:oMath>
+                  </m:oMathPara>
+                </a14:m>
+                <a:endParaRPr lang="en-US" dirty="0"/>
+              </a:p>
+              <a:p>
+                <a:pPr lvl="0"/>
+                <a:r>
+                  <a:rPr lang="en-US" dirty="0"/>
+                  <a:t>We need to estimate the probabilities for the ranks   </a:t>
+                </a:r>
+              </a:p>
+              <a:p>
+                <a:pPr lvl="1"/>
+                <a:r>
+                  <a:rPr lang="en-US" dirty="0"/>
+                  <a:t>Logit model uses proportional odds of the ranks      </a:t>
+                </a:r>
+              </a:p>
+              <a:p>
+                <a:pPr lvl="1"/>
+                <a:r>
+                  <a:rPr lang="en-US" dirty="0"/>
+                  <a:t>Probit model estimates ranks based on order CDF of the </a:t>
+                </a:r>
+                <a:r>
+                  <a:rPr lang="en-US"/>
+                  <a:t>Normal distribution </a:t>
+                </a:r>
+                <a:endParaRPr dirty="0"/>
+              </a:p>
+            </p:txBody>
+          </p:sp>
+        </mc:Choice>
+        <mc:Fallback>
+          <p:sp>
+            <p:nvSpPr>
+              <p:cNvPr id="3" name="Content Placeholder 2">
+                <a:extLst>
+                  <a:ext uri="{FF2B5EF4-FFF2-40B4-BE49-F238E27FC236}">
+                    <a16:creationId xmlns:a16="http://schemas.microsoft.com/office/drawing/2014/main" id="{CB6070E2-70F7-A018-6E47-2030E69C1725}"/>
+                  </a:ext>
+                </a:extLst>
+              </p:cNvPr>
+              <p:cNvSpPr>
+                <a:spLocks noGrp="1" noRot="1" noChangeAspect="1" noMove="1" noResize="1" noEditPoints="1" noAdjustHandles="1" noChangeArrowheads="1" noChangeShapeType="1" noTextEdit="1"/>
+              </p:cNvSpPr>
+              <p:nvPr>
+                <p:ph idx="1"/>
+              </p:nvPr>
+            </p:nvSpPr>
+            <p:spPr>
+              <a:blipFill>
+                <a:blip r:embed="rId2"/>
+                <a:stretch>
+                  <a:fillRect l="-1111" t="-1436"/>
+                </a:stretch>
+              </a:blipFill>
+            </p:spPr>
+            <p:txBody>
+              <a:bodyPr/>
+              <a:lstStyle/>
+              <a:p>
+                <a:r>
+                  <a:rPr lang="en-US">
+                    <a:noFill/>
+                  </a:rPr>
+                  <a:t> </a:t>
+                </a:r>
+              </a:p>
+            </p:txBody>
+          </p:sp>
+        </mc:Fallback>
+      </mc:AlternateContent>
+    </p:spTree>
+    <p:extLst>
+      <p:ext uri="{BB962C8B-B14F-4D97-AF65-F5344CB8AC3E}">
+        <p14:creationId xmlns:p14="http://schemas.microsoft.com/office/powerpoint/2010/main" val="4227940440"/>
+      </p:ext>
+    </p:extLst>
+  </p:cSld>
+  <p:clrMapOvr>
+    <a:masterClrMapping/>
+  </p:clrMapOvr>
+</p:sld>
+</file>
+
+<file path=ppt/slides/slide64.xml><?xml version="1.0" encoding="utf-8"?>
+<p:sld xmlns:a="http://schemas.openxmlformats.org/drawingml/2006/main" xmlns:r="http://schemas.openxmlformats.org/officeDocument/2006/relationships" xmlns:p="http://schemas.openxmlformats.org/presentationml/2006/main">
+  <p:cSld>
+    <p:spTree>
+      <p:nvGrpSpPr>
+        <p:cNvPr id="1" name="">
+          <a:extLst>
+            <a:ext uri="{FF2B5EF4-FFF2-40B4-BE49-F238E27FC236}">
+              <a16:creationId xmlns:a16="http://schemas.microsoft.com/office/drawing/2014/main" id="{1039353C-1F79-D0FC-1EBA-842771A6D5CE}"/>
+            </a:ext>
+          </a:extLst>
+        </p:cNvPr>
+        <p:cNvGrpSpPr/>
+        <p:nvPr/>
+      </p:nvGrpSpPr>
+      <p:grpSpPr>
+        <a:xfrm>
+          <a:off x="0" y="0"/>
+          <a:ext cx="0" cy="0"/>
+          <a:chOff x="0" y="0"/>
+          <a:chExt cx="0" cy="0"/>
+        </a:xfrm>
+      </p:grpSpPr>
+      <p:sp>
+        <p:nvSpPr>
+          <p:cNvPr id="2" name="Title 1">
+            <a:extLst>
+              <a:ext uri="{FF2B5EF4-FFF2-40B4-BE49-F238E27FC236}">
+                <a16:creationId xmlns:a16="http://schemas.microsoft.com/office/drawing/2014/main" id="{6CD90C8A-9A28-C47A-C735-0E8097187539}"/>
+              </a:ext>
+            </a:extLst>
+          </p:cNvPr>
+          <p:cNvSpPr>
+            <a:spLocks noGrp="1"/>
+          </p:cNvSpPr>
+          <p:nvPr>
+            <p:ph type="ctrTitle"/>
+          </p:nvPr>
+        </p:nvSpPr>
+        <p:spPr/>
+        <p:txBody>
+          <a:bodyPr/>
+          <a:lstStyle/>
+          <a:p>
+            <a:r>
+              <a:rPr lang="en-US" dirty="0"/>
+              <a:t>Summary</a:t>
+            </a:r>
+          </a:p>
+        </p:txBody>
+      </p:sp>
+    </p:spTree>
+    <p:extLst>
+      <p:ext uri="{BB962C8B-B14F-4D97-AF65-F5344CB8AC3E}">
+        <p14:creationId xmlns:p14="http://schemas.microsoft.com/office/powerpoint/2010/main" val="956940509"/>
+      </p:ext>
+    </p:extLst>
+  </p:cSld>
+  <p:clrMapOvr>
+    <a:masterClrMapping/>
+  </p:clrMapOvr>
+</p:sld>
+</file>
+
+<file path=ppt/slides/slide65.xml><?xml version="1.0" encoding="utf-8"?>
+<p:sld xmlns:a="http://schemas.openxmlformats.org/drawingml/2006/main" xmlns:r="http://schemas.openxmlformats.org/officeDocument/2006/relationships" xmlns:p="http://schemas.openxmlformats.org/presentationml/2006/main">
+  <p:cSld>
+    <p:spTree>
+      <p:nvGrpSpPr>
+        <p:cNvPr id="1" name="">
+          <a:extLst>
+            <a:ext uri="{FF2B5EF4-FFF2-40B4-BE49-F238E27FC236}">
               <a16:creationId xmlns:a16="http://schemas.microsoft.com/office/drawing/2014/main" id="{E5403FAB-44AB-D252-6A94-8C4F7285DFCC}"/>
             </a:ext>
           </a:extLst>
@@ -43753,7 +44386,7 @@
 </p:sld>
 </file>
 
-<file path=ppt/slides/slide62.xml><?xml version="1.0" encoding="utf-8"?>
+<file path=ppt/slides/slide66.xml><?xml version="1.0" encoding="utf-8"?>
 <p:sld xmlns:a="http://schemas.openxmlformats.org/drawingml/2006/main" xmlns:r="http://schemas.openxmlformats.org/officeDocument/2006/relationships" xmlns:p="http://schemas.openxmlformats.org/presentationml/2006/main">
   <p:cSld>
     <p:spTree>

</xml_diff>